<commit_message>
Tidy code box on polynomial slide
Co-Authored-By: Claude Fable 5.1 <noreply@anthropic.com>
Claude-Session: https://claude.ai/code/session_01VSxQY4zC3ss8v2MbXjeYwJ
</commit_message>
<xml_diff>
--- a/Assessment_Solutions/presentation/Formative_Assessment_Presentation.pptx
+++ b/Assessment_Solutions/presentation/Formative_Assessment_Presentation.pptx
@@ -14572,7 +14572,7 @@
                 </a:solidFill>
                 <a:latin typeface="Consolas"/>
               </a:rPr>
-              <a:t>model &lt;- lm(response ~ dose + I(dose^2), data = trial)</a:t>
+              <a:t>model &lt;- lm(response ~ dose + I(dose^2),</a:t>
             </a:r>
           </a:p>
           <a:p>
@@ -14580,11 +14580,23 @@
             <a:r>
               <a:rPr sz="1300">
                 <a:solidFill>
+                  <a:srgbClr val="222222"/>
+                </a:solidFill>
+                <a:latin typeface="Consolas"/>
+              </a:rPr>
+              <a:t>            data = trial)</a:t>
+            </a:r>
+          </a:p>
+          <a:p>
+            <a:pPr algn="l"/>
+            <a:r>
+              <a:rPr sz="1300">
+                <a:solidFill>
                   <a:srgbClr val="1F3A5F"/>
                 </a:solidFill>
                 <a:latin typeface="Consolas"/>
               </a:rPr>
-              <a:t># or   lm(response ~ poly(dose, 2), data = trial)</a:t>
+              <a:t># or:  lm(response ~ poly(dose, 2), data = trial)</a:t>
             </a:r>
           </a:p>
         </p:txBody>

</xml_diff>